<commit_message>
Calibra a impressao dos slides e simplifica o pptx tambem
O PDF gerado da pagina vazava conteudo entre paginas: o clamp() das fontes
depende da largura da janela, que no PDF nao existe do mesmo jeito. O bloco
de impressao agora fixa os tamanhos em pontos, calibrados para caber nos
190 mm de altura de cada lamina.

Leva para o PowerPoint a mesma linguagem simples da pagina: gunicorn virou
o porteiro, Flask o cerebro, SQLAlchemy o tradutor, psycopg o cabo,
PostgreSQL o cofre e Jinja o molde.

Exporta tambem docs/cafes.json com os 12 cafes direto da producao.

Co-Authored-By: Claude Opus 5 <noreply@anthropic.com>
</commit_message>
<xml_diff>
--- a/docs/Processo_Torra_e_Terra.pptx
+++ b/docs/Processo_Torra_e_Terra.pptx
@@ -5870,7 +5870,7 @@
                 <a:ea typeface="Cambria" pitchFamily="34" charset="-122"/>
                 <a:cs typeface="Cambria" pitchFamily="34" charset="-120"/>
               </a:rPr>
-              <a:t>Arquitetura e linguagens</a:t>
+              <a:t>Como o site funciona por dentro</a:t>
             </a:r>
             <a:endParaRPr lang="en-US" sz="3400" dirty="0"/>
           </a:p>
@@ -5909,7 +5909,7 @@
                 <a:ea typeface="Calibri" pitchFamily="34" charset="-122"/>
                 <a:cs typeface="Calibri" pitchFamily="34" charset="-120"/>
               </a:rPr>
-              <a:t>O caminho que uma requisição percorre, da barra de endereço até o disco.</a:t>
+              <a:t>O caminho que um clique percorre — do navegador do cliente até o dado guardado no banco.</a:t>
             </a:r>
             <a:endParaRPr lang="en-US" sz="1400" dirty="0"/>
           </a:p>
@@ -6014,7 +6014,7 @@
                 <a:ea typeface="Calibri" pitchFamily="34" charset="-122"/>
                 <a:cs typeface="Calibri" pitchFamily="34" charset="-120"/>
               </a:rPr>
-              <a:t>HTML · CSS</a:t>
+              <a:t>o cliente clica</a:t>
             </a:r>
             <a:endParaRPr lang="en-US" sz="1050" dirty="0"/>
           </a:p>
@@ -6158,7 +6158,7 @@
                 <a:ea typeface="Calibri" pitchFamily="34" charset="-122"/>
                 <a:cs typeface="Calibri" pitchFamily="34" charset="-120"/>
               </a:rPr>
-              <a:t>servidor WSGI</a:t>
+              <a:t>atende o pedido</a:t>
             </a:r>
             <a:endParaRPr lang="en-US" sz="1050" dirty="0"/>
           </a:p>
@@ -6302,7 +6302,7 @@
                 <a:ea typeface="Calibri" pitchFamily="34" charset="-122"/>
                 <a:cs typeface="Calibri" pitchFamily="34" charset="-120"/>
               </a:rPr>
-              <a:t>rotas e regras</a:t>
+              <a:t>decide o que fazer</a:t>
             </a:r>
             <a:endParaRPr lang="en-US" sz="1050" dirty="0"/>
           </a:p>
@@ -6446,7 +6446,7 @@
                 <a:ea typeface="Calibri" pitchFamily="34" charset="-122"/>
                 <a:cs typeface="Calibri" pitchFamily="34" charset="-120"/>
               </a:rPr>
-              <a:t>ORM</a:t>
+              <a:t>traduz para SQL</a:t>
             </a:r>
             <a:endParaRPr lang="en-US" sz="1050" dirty="0"/>
           </a:p>
@@ -6551,7 +6551,7 @@
                 <a:ea typeface="Calibri" pitchFamily="34" charset="-122"/>
                 <a:cs typeface="Calibri" pitchFamily="34" charset="-120"/>
               </a:rPr>
-              <a:t>psycopg 3</a:t>
+              <a:t>psycopg</a:t>
             </a:r>
             <a:endParaRPr lang="en-US" sz="1250" dirty="0"/>
           </a:p>
@@ -6590,7 +6590,7 @@
                 <a:ea typeface="Calibri" pitchFamily="34" charset="-122"/>
                 <a:cs typeface="Calibri" pitchFamily="34" charset="-120"/>
               </a:rPr>
-              <a:t>driver</a:t>
+              <a:t>fala com o banco</a:t>
             </a:r>
             <a:endParaRPr lang="en-US" sz="1050" dirty="0"/>
           </a:p>
@@ -6734,7 +6734,7 @@
                 <a:ea typeface="Calibri" pitchFamily="34" charset="-122"/>
                 <a:cs typeface="Calibri" pitchFamily="34" charset="-120"/>
               </a:rPr>
-              <a:t>SQL</a:t>
+              <a:t>guarda o dado</a:t>
             </a:r>
             <a:endParaRPr lang="en-US" sz="1050" dirty="0"/>
           </a:p>
@@ -6773,7 +6773,7 @@
                 <a:ea typeface="Calibri" pitchFamily="34" charset="-122"/>
                 <a:cs typeface="Calibri" pitchFamily="34" charset="-120"/>
               </a:rPr>
-              <a:t>CADA CAMADA E A SUA LINGUAGEM</a:t>
+              <a:t>O QUE É CADA PEÇA, EM UMA FRASE</a:t>
             </a:r>
             <a:endParaRPr lang="en-US" sz="1000" dirty="0"/>
           </a:p>
@@ -6787,7 +6787,7 @@
         </p:nvSpPr>
         <p:spPr>
           <a:xfrm>
-            <a:off x="640080" y="3566160"/>
+            <a:off x="640080" y="3547872"/>
             <a:ext cx="1417320" cy="365760"/>
           </a:xfrm>
           <a:prstGeom prst="rect">
@@ -6804,7 +6804,7 @@
               <a:buNone/>
             </a:pPr>
             <a:r>
-              <a:rPr lang="en-US" sz="1300" b="1" dirty="0">
+              <a:rPr lang="en-US" sz="1150" b="1" dirty="0">
                 <a:solidFill>
                   <a:srgbClr val="14120F"/>
                 </a:solidFill>
@@ -6812,9 +6812,9 @@
                 <a:ea typeface="Calibri" pitchFamily="34" charset="-122"/>
                 <a:cs typeface="Calibri" pitchFamily="34" charset="-120"/>
               </a:rPr>
-              <a:t>Interface</a:t>
-            </a:r>
-            <a:endParaRPr lang="en-US" sz="1300" dirty="0"/>
+              <a:t>gunicorn</a:t>
+            </a:r>
+            <a:endParaRPr lang="en-US" sz="1150" dirty="0"/>
           </a:p>
         </p:txBody>
       </p:sp>
@@ -6826,24 +6826,24 @@
         </p:nvSpPr>
         <p:spPr>
           <a:xfrm>
-            <a:off x="2103120" y="3566160"/>
-            <a:ext cx="3200400" cy="365760"/>
-          </a:xfrm>
-          <a:prstGeom prst="rect">
-            <a:avLst/>
-          </a:prstGeom>
-          <a:noFill/>
-          <a:ln/>
-        </p:spPr>
-        <p:txBody>
-          <a:bodyPr wrap="square" lIns="0" tIns="0" rIns="0" bIns="0" rtlCol="0" anchor="ctr"/>
-          <a:lstStyle/>
-          <a:p>
-            <a:pPr indent="0" marL="0">
-              <a:buNone/>
-            </a:pPr>
-            <a:r>
-              <a:rPr lang="en-US" sz="1200" dirty="0">
+            <a:off x="2103120" y="3547872"/>
+            <a:ext cx="1188720" cy="365760"/>
+          </a:xfrm>
+          <a:prstGeom prst="rect">
+            <a:avLst/>
+          </a:prstGeom>
+          <a:noFill/>
+          <a:ln/>
+        </p:spPr>
+        <p:txBody>
+          <a:bodyPr wrap="square" lIns="0" tIns="0" rIns="0" bIns="0" rtlCol="0" anchor="ctr"/>
+          <a:lstStyle/>
+          <a:p>
+            <a:pPr indent="0" marL="0">
+              <a:buNone/>
+            </a:pPr>
+            <a:r>
+              <a:rPr lang="en-US" sz="1050" dirty="0">
                 <a:solidFill>
                   <a:srgbClr val="D4622A"/>
                 </a:solidFill>
@@ -6851,9 +6851,9 @@
                 <a:ea typeface="Consolas" pitchFamily="34" charset="-122"/>
                 <a:cs typeface="Consolas" pitchFamily="34" charset="-120"/>
               </a:rPr>
-              <a:t>HTML, CSS e Jinja2</a:t>
-            </a:r>
-            <a:endParaRPr lang="en-US" sz="1200" dirty="0"/>
+              <a:t>Python</a:t>
+            </a:r>
+            <a:endParaRPr lang="en-US" sz="1050" dirty="0"/>
           </a:p>
         </p:txBody>
       </p:sp>
@@ -6865,24 +6865,24 @@
         </p:nvSpPr>
         <p:spPr>
           <a:xfrm>
-            <a:off x="5394960" y="3566160"/>
-            <a:ext cx="6035040" cy="365760"/>
-          </a:xfrm>
-          <a:prstGeom prst="rect">
-            <a:avLst/>
-          </a:prstGeom>
-          <a:noFill/>
-          <a:ln/>
-        </p:spPr>
-        <p:txBody>
-          <a:bodyPr wrap="square" lIns="0" tIns="0" rIns="0" bIns="0" rtlCol="0" anchor="ctr"/>
-          <a:lstStyle/>
-          <a:p>
-            <a:pPr indent="0" marL="0">
-              <a:buNone/>
-            </a:pPr>
-            <a:r>
-              <a:rPr lang="en-US" sz="1200" dirty="0">
+            <a:off x="3383280" y="3547872"/>
+            <a:ext cx="8138160" cy="365760"/>
+          </a:xfrm>
+          <a:prstGeom prst="rect">
+            <a:avLst/>
+          </a:prstGeom>
+          <a:noFill/>
+          <a:ln/>
+        </p:spPr>
+        <p:txBody>
+          <a:bodyPr wrap="square" lIns="0" tIns="0" rIns="0" bIns="0" rtlCol="0" anchor="ctr"/>
+          <a:lstStyle/>
+          <a:p>
+            <a:pPr indent="0" marL="0">
+              <a:buNone/>
+            </a:pPr>
+            <a:r>
+              <a:rPr lang="en-US" sz="1100" dirty="0">
                 <a:solidFill>
                   <a:srgbClr val="6B6560"/>
                 </a:solidFill>
@@ -6890,9 +6890,9 @@
                 <a:ea typeface="Calibri" pitchFamily="34" charset="-122"/>
                 <a:cs typeface="Calibri" pitchFamily="34" charset="-120"/>
               </a:rPr>
-              <a:t>CSS puro, sem framework — nem Bootstrap, nem Tailwind</a:t>
-            </a:r>
-            <a:endParaRPr lang="en-US" sz="1200" dirty="0"/>
+              <a:t>É o PORTEIRO. Escuta a internet e entrega cada acesso para o Python.</a:t>
+            </a:r>
+            <a:endParaRPr lang="en-US" sz="1100" dirty="0"/>
           </a:p>
         </p:txBody>
       </p:sp>
@@ -6904,7 +6904,7 @@
         </p:nvSpPr>
         <p:spPr>
           <a:xfrm>
-            <a:off x="640080" y="4169664"/>
+            <a:off x="640080" y="3959352"/>
             <a:ext cx="1417320" cy="365760"/>
           </a:xfrm>
           <a:prstGeom prst="rect">
@@ -6921,7 +6921,7 @@
               <a:buNone/>
             </a:pPr>
             <a:r>
-              <a:rPr lang="en-US" sz="1300" b="1" dirty="0">
+              <a:rPr lang="en-US" sz="1150" b="1" dirty="0">
                 <a:solidFill>
                   <a:srgbClr val="14120F"/>
                 </a:solidFill>
@@ -6929,9 +6929,9 @@
                 <a:ea typeface="Calibri" pitchFamily="34" charset="-122"/>
                 <a:cs typeface="Calibri" pitchFamily="34" charset="-120"/>
               </a:rPr>
-              <a:t>Aplicação</a:t>
-            </a:r>
-            <a:endParaRPr lang="en-US" sz="1300" dirty="0"/>
+              <a:t>Flask</a:t>
+            </a:r>
+            <a:endParaRPr lang="en-US" sz="1150" dirty="0"/>
           </a:p>
         </p:txBody>
       </p:sp>
@@ -6943,24 +6943,24 @@
         </p:nvSpPr>
         <p:spPr>
           <a:xfrm>
-            <a:off x="2103120" y="4169664"/>
-            <a:ext cx="3200400" cy="365760"/>
-          </a:xfrm>
-          <a:prstGeom prst="rect">
-            <a:avLst/>
-          </a:prstGeom>
-          <a:noFill/>
-          <a:ln/>
-        </p:spPr>
-        <p:txBody>
-          <a:bodyPr wrap="square" lIns="0" tIns="0" rIns="0" bIns="0" rtlCol="0" anchor="ctr"/>
-          <a:lstStyle/>
-          <a:p>
-            <a:pPr indent="0" marL="0">
-              <a:buNone/>
-            </a:pPr>
-            <a:r>
-              <a:rPr lang="en-US" sz="1200" dirty="0">
+            <a:off x="2103120" y="3959352"/>
+            <a:ext cx="1188720" cy="365760"/>
+          </a:xfrm>
+          <a:prstGeom prst="rect">
+            <a:avLst/>
+          </a:prstGeom>
+          <a:noFill/>
+          <a:ln/>
+        </p:spPr>
+        <p:txBody>
+          <a:bodyPr wrap="square" lIns="0" tIns="0" rIns="0" bIns="0" rtlCol="0" anchor="ctr"/>
+          <a:lstStyle/>
+          <a:p>
+            <a:pPr indent="0" marL="0">
+              <a:buNone/>
+            </a:pPr>
+            <a:r>
+              <a:rPr lang="en-US" sz="1050" dirty="0">
                 <a:solidFill>
                   <a:srgbClr val="D4622A"/>
                 </a:solidFill>
@@ -6968,9 +6968,9 @@
                 <a:ea typeface="Consolas" pitchFamily="34" charset="-122"/>
                 <a:cs typeface="Consolas" pitchFamily="34" charset="-120"/>
               </a:rPr>
-              <a:t>Python 3.11 com Flask</a:t>
-            </a:r>
-            <a:endParaRPr lang="en-US" sz="1200" dirty="0"/>
+              <a:t>Python</a:t>
+            </a:r>
+            <a:endParaRPr lang="en-US" sz="1050" dirty="0"/>
           </a:p>
         </p:txBody>
       </p:sp>
@@ -6982,24 +6982,24 @@
         </p:nvSpPr>
         <p:spPr>
           <a:xfrm>
-            <a:off x="5394960" y="4169664"/>
-            <a:ext cx="6035040" cy="365760"/>
-          </a:xfrm>
-          <a:prstGeom prst="rect">
-            <a:avLst/>
-          </a:prstGeom>
-          <a:noFill/>
-          <a:ln/>
-        </p:spPr>
-        <p:txBody>
-          <a:bodyPr wrap="square" lIns="0" tIns="0" rIns="0" bIns="0" rtlCol="0" anchor="ctr"/>
-          <a:lstStyle/>
-          <a:p>
-            <a:pPr indent="0" marL="0">
-              <a:buNone/>
-            </a:pPr>
-            <a:r>
-              <a:rPr lang="en-US" sz="1200" dirty="0">
+            <a:off x="3383280" y="3959352"/>
+            <a:ext cx="8138160" cy="365760"/>
+          </a:xfrm>
+          <a:prstGeom prst="rect">
+            <a:avLst/>
+          </a:prstGeom>
+          <a:noFill/>
+          <a:ln/>
+        </p:spPr>
+        <p:txBody>
+          <a:bodyPr wrap="square" lIns="0" tIns="0" rIns="0" bIns="0" rtlCol="0" anchor="ctr"/>
+          <a:lstStyle/>
+          <a:p>
+            <a:pPr indent="0" marL="0">
+              <a:buNone/>
+            </a:pPr>
+            <a:r>
+              <a:rPr lang="en-US" sz="1100" dirty="0">
                 <a:solidFill>
                   <a:srgbClr val="6B6560"/>
                 </a:solidFill>
@@ -7007,9 +7007,9 @@
                 <a:ea typeface="Calibri" pitchFamily="34" charset="-122"/>
                 <a:cs typeface="Calibri" pitchFamily="34" charset="-120"/>
               </a:rPr>
-              <a:t>rotas, sessão e as regras de negócio</a:t>
-            </a:r>
-            <a:endParaRPr lang="en-US" sz="1200" dirty="0"/>
+              <a:t>É o CÉREBRO. Decide o que responder, e é onde moram as regras.</a:t>
+            </a:r>
+            <a:endParaRPr lang="en-US" sz="1100" dirty="0"/>
           </a:p>
         </p:txBody>
       </p:sp>
@@ -7021,7 +7021,7 @@
         </p:nvSpPr>
         <p:spPr>
           <a:xfrm>
-            <a:off x="640080" y="4773168"/>
+            <a:off x="640080" y="4370832"/>
             <a:ext cx="1417320" cy="365760"/>
           </a:xfrm>
           <a:prstGeom prst="rect">
@@ -7038,7 +7038,7 @@
               <a:buNone/>
             </a:pPr>
             <a:r>
-              <a:rPr lang="en-US" sz="1300" b="1" dirty="0">
+              <a:rPr lang="en-US" sz="1150" b="1" dirty="0">
                 <a:solidFill>
                   <a:srgbClr val="14120F"/>
                 </a:solidFill>
@@ -7046,9 +7046,9 @@
                 <a:ea typeface="Calibri" pitchFamily="34" charset="-122"/>
                 <a:cs typeface="Calibri" pitchFamily="34" charset="-120"/>
               </a:rPr>
-              <a:t>Persistência</a:t>
-            </a:r>
-            <a:endParaRPr lang="en-US" sz="1300" dirty="0"/>
+              <a:t>SQLAlchemy</a:t>
+            </a:r>
+            <a:endParaRPr lang="en-US" sz="1150" dirty="0"/>
           </a:p>
         </p:txBody>
       </p:sp>
@@ -7060,24 +7060,24 @@
         </p:nvSpPr>
         <p:spPr>
           <a:xfrm>
-            <a:off x="2103120" y="4773168"/>
-            <a:ext cx="3200400" cy="365760"/>
-          </a:xfrm>
-          <a:prstGeom prst="rect">
-            <a:avLst/>
-          </a:prstGeom>
-          <a:noFill/>
-          <a:ln/>
-        </p:spPr>
-        <p:txBody>
-          <a:bodyPr wrap="square" lIns="0" tIns="0" rIns="0" bIns="0" rtlCol="0" anchor="ctr"/>
-          <a:lstStyle/>
-          <a:p>
-            <a:pPr indent="0" marL="0">
-              <a:buNone/>
-            </a:pPr>
-            <a:r>
-              <a:rPr lang="en-US" sz="1200" dirty="0">
+            <a:off x="2103120" y="4370832"/>
+            <a:ext cx="1188720" cy="365760"/>
+          </a:xfrm>
+          <a:prstGeom prst="rect">
+            <a:avLst/>
+          </a:prstGeom>
+          <a:noFill/>
+          <a:ln/>
+        </p:spPr>
+        <p:txBody>
+          <a:bodyPr wrap="square" lIns="0" tIns="0" rIns="0" bIns="0" rtlCol="0" anchor="ctr"/>
+          <a:lstStyle/>
+          <a:p>
+            <a:pPr indent="0" marL="0">
+              <a:buNone/>
+            </a:pPr>
+            <a:r>
+              <a:rPr lang="en-US" sz="1050" dirty="0">
                 <a:solidFill>
                   <a:srgbClr val="D4622A"/>
                 </a:solidFill>
@@ -7085,9 +7085,9 @@
                 <a:ea typeface="Consolas" pitchFamily="34" charset="-122"/>
                 <a:cs typeface="Consolas" pitchFamily="34" charset="-120"/>
               </a:rPr>
-              <a:t>SQLAlchemy sobre psycopg 3</a:t>
-            </a:r>
-            <a:endParaRPr lang="en-US" sz="1200" dirty="0"/>
+              <a:t>Python</a:t>
+            </a:r>
+            <a:endParaRPr lang="en-US" sz="1050" dirty="0"/>
           </a:p>
         </p:txBody>
       </p:sp>
@@ -7099,24 +7099,24 @@
         </p:nvSpPr>
         <p:spPr>
           <a:xfrm>
-            <a:off x="5394960" y="4773168"/>
-            <a:ext cx="6035040" cy="365760"/>
-          </a:xfrm>
-          <a:prstGeom prst="rect">
-            <a:avLst/>
-          </a:prstGeom>
-          <a:noFill/>
-          <a:ln/>
-        </p:spPr>
-        <p:txBody>
-          <a:bodyPr wrap="square" lIns="0" tIns="0" rIns="0" bIns="0" rtlCol="0" anchor="ctr"/>
-          <a:lstStyle/>
-          <a:p>
-            <a:pPr indent="0" marL="0">
-              <a:buNone/>
-            </a:pPr>
-            <a:r>
-              <a:rPr lang="en-US" sz="1200" dirty="0">
+            <a:off x="3383280" y="4370832"/>
+            <a:ext cx="8138160" cy="365760"/>
+          </a:xfrm>
+          <a:prstGeom prst="rect">
+            <a:avLst/>
+          </a:prstGeom>
+          <a:noFill/>
+          <a:ln/>
+        </p:spPr>
+        <p:txBody>
+          <a:bodyPr wrap="square" lIns="0" tIns="0" rIns="0" bIns="0" rtlCol="0" anchor="ctr"/>
+          <a:lstStyle/>
+          <a:p>
+            <a:pPr indent="0" marL="0">
+              <a:buNone/>
+            </a:pPr>
+            <a:r>
+              <a:rPr lang="en-US" sz="1100" dirty="0">
                 <a:solidFill>
                   <a:srgbClr val="6B6560"/>
                 </a:solidFill>
@@ -7124,9 +7124,9 @@
                 <a:ea typeface="Calibri" pitchFamily="34" charset="-122"/>
                 <a:cs typeface="Calibri" pitchFamily="34" charset="-120"/>
               </a:rPr>
-              <a:t>os modelos espelham o schema, não o geram</a:t>
-            </a:r>
-            <a:endParaRPr lang="en-US" sz="1200" dirty="0"/>
+              <a:t>É o TRADUTOR. A gente escreve em Python, ele converte para SQL.</a:t>
+            </a:r>
+            <a:endParaRPr lang="en-US" sz="1100" dirty="0"/>
           </a:p>
         </p:txBody>
       </p:sp>
@@ -7138,7 +7138,7 @@
         </p:nvSpPr>
         <p:spPr>
           <a:xfrm>
-            <a:off x="640080" y="5376672"/>
+            <a:off x="640080" y="4782312"/>
             <a:ext cx="1417320" cy="365760"/>
           </a:xfrm>
           <a:prstGeom prst="rect">
@@ -7155,7 +7155,7 @@
               <a:buNone/>
             </a:pPr>
             <a:r>
-              <a:rPr lang="en-US" sz="1300" b="1" dirty="0">
+              <a:rPr lang="en-US" sz="1150" b="1" dirty="0">
                 <a:solidFill>
                   <a:srgbClr val="14120F"/>
                 </a:solidFill>
@@ -7163,9 +7163,9 @@
                 <a:ea typeface="Calibri" pitchFamily="34" charset="-122"/>
                 <a:cs typeface="Calibri" pitchFamily="34" charset="-120"/>
               </a:rPr>
-              <a:t>Banco</a:t>
-            </a:r>
-            <a:endParaRPr lang="en-US" sz="1300" dirty="0"/>
+              <a:t>psycopg</a:t>
+            </a:r>
+            <a:endParaRPr lang="en-US" sz="1150" dirty="0"/>
           </a:p>
         </p:txBody>
       </p:sp>
@@ -7177,24 +7177,24 @@
         </p:nvSpPr>
         <p:spPr>
           <a:xfrm>
-            <a:off x="2103120" y="5376672"/>
-            <a:ext cx="3200400" cy="365760"/>
-          </a:xfrm>
-          <a:prstGeom prst="rect">
-            <a:avLst/>
-          </a:prstGeom>
-          <a:noFill/>
-          <a:ln/>
-        </p:spPr>
-        <p:txBody>
-          <a:bodyPr wrap="square" lIns="0" tIns="0" rIns="0" bIns="0" rtlCol="0" anchor="ctr"/>
-          <a:lstStyle/>
-          <a:p>
-            <a:pPr indent="0" marL="0">
-              <a:buNone/>
-            </a:pPr>
-            <a:r>
-              <a:rPr lang="en-US" sz="1200" dirty="0">
+            <a:off x="2103120" y="4782312"/>
+            <a:ext cx="1188720" cy="365760"/>
+          </a:xfrm>
+          <a:prstGeom prst="rect">
+            <a:avLst/>
+          </a:prstGeom>
+          <a:noFill/>
+          <a:ln/>
+        </p:spPr>
+        <p:txBody>
+          <a:bodyPr wrap="square" lIns="0" tIns="0" rIns="0" bIns="0" rtlCol="0" anchor="ctr"/>
+          <a:lstStyle/>
+          <a:p>
+            <a:pPr indent="0" marL="0">
+              <a:buNone/>
+            </a:pPr>
+            <a:r>
+              <a:rPr lang="en-US" sz="1050" dirty="0">
                 <a:solidFill>
                   <a:srgbClr val="D4622A"/>
                 </a:solidFill>
@@ -7202,9 +7202,9 @@
                 <a:ea typeface="Consolas" pitchFamily="34" charset="-122"/>
                 <a:cs typeface="Consolas" pitchFamily="34" charset="-120"/>
               </a:rPr>
-              <a:t>SQL — DDL escrito à mão</a:t>
-            </a:r>
-            <a:endParaRPr lang="en-US" sz="1200" dirty="0"/>
+              <a:t>Python</a:t>
+            </a:r>
+            <a:endParaRPr lang="en-US" sz="1050" dirty="0"/>
           </a:p>
         </p:txBody>
       </p:sp>
@@ -7216,24 +7216,24 @@
         </p:nvSpPr>
         <p:spPr>
           <a:xfrm>
-            <a:off x="5394960" y="5376672"/>
-            <a:ext cx="6035040" cy="365760"/>
-          </a:xfrm>
-          <a:prstGeom prst="rect">
-            <a:avLst/>
-          </a:prstGeom>
-          <a:noFill/>
-          <a:ln/>
-        </p:spPr>
-        <p:txBody>
-          <a:bodyPr wrap="square" lIns="0" tIns="0" rIns="0" bIns="0" rtlCol="0" anchor="ctr"/>
-          <a:lstStyle/>
-          <a:p>
-            <a:pPr indent="0" marL="0">
-              <a:buNone/>
-            </a:pPr>
-            <a:r>
-              <a:rPr lang="en-US" sz="1200" dirty="0">
+            <a:off x="3383280" y="4782312"/>
+            <a:ext cx="8138160" cy="365760"/>
+          </a:xfrm>
+          <a:prstGeom prst="rect">
+            <a:avLst/>
+          </a:prstGeom>
+          <a:noFill/>
+          <a:ln/>
+        </p:spPr>
+        <p:txBody>
+          <a:bodyPr wrap="square" lIns="0" tIns="0" rIns="0" bIns="0" rtlCol="0" anchor="ctr"/>
+          <a:lstStyle/>
+          <a:p>
+            <a:pPr indent="0" marL="0">
+              <a:buNone/>
+            </a:pPr>
+            <a:r>
+              <a:rPr lang="en-US" sz="1100" dirty="0">
                 <a:solidFill>
                   <a:srgbClr val="6B6560"/>
                 </a:solidFill>
@@ -7241,9 +7241,9 @@
                 <a:ea typeface="Calibri" pitchFamily="34" charset="-122"/>
                 <a:cs typeface="Calibri" pitchFamily="34" charset="-120"/>
               </a:rPr>
-              <a:t>é onde as constraints vivem e são auditáveis</a:t>
-            </a:r>
-            <a:endParaRPr lang="en-US" sz="1200" dirty="0"/>
+              <a:t>É o CABO. Leva o comando até o PostgreSQL e traz a resposta.</a:t>
+            </a:r>
+            <a:endParaRPr lang="en-US" sz="1100" dirty="0"/>
           </a:p>
         </p:txBody>
       </p:sp>
@@ -7255,7 +7255,241 @@
         </p:nvSpPr>
         <p:spPr>
           <a:xfrm>
-            <a:off x="640080" y="5989320"/>
+            <a:off x="640080" y="5193792"/>
+            <a:ext cx="1417320" cy="365760"/>
+          </a:xfrm>
+          <a:prstGeom prst="rect">
+            <a:avLst/>
+          </a:prstGeom>
+          <a:noFill/>
+          <a:ln/>
+        </p:spPr>
+        <p:txBody>
+          <a:bodyPr wrap="square" lIns="0" tIns="0" rIns="0" bIns="0" rtlCol="0" anchor="ctr"/>
+          <a:lstStyle/>
+          <a:p>
+            <a:pPr indent="0" marL="0">
+              <a:buNone/>
+            </a:pPr>
+            <a:r>
+              <a:rPr lang="en-US" sz="1150" b="1" dirty="0">
+                <a:solidFill>
+                  <a:srgbClr val="14120F"/>
+                </a:solidFill>
+                <a:latin typeface="Calibri" pitchFamily="34" charset="0"/>
+                <a:ea typeface="Calibri" pitchFamily="34" charset="-122"/>
+                <a:cs typeface="Calibri" pitchFamily="34" charset="-120"/>
+              </a:rPr>
+              <a:t>PostgreSQL</a:t>
+            </a:r>
+            <a:endParaRPr lang="en-US" sz="1150" dirty="0"/>
+          </a:p>
+        </p:txBody>
+      </p:sp>
+      <p:sp>
+        <p:nvSpPr>
+          <p:cNvPr id="41" name="Text 39"/>
+          <p:cNvSpPr txBox="1"/>
+          <p:nvPr/>
+        </p:nvSpPr>
+        <p:spPr>
+          <a:xfrm>
+            <a:off x="2103120" y="5193792"/>
+            <a:ext cx="1188720" cy="365760"/>
+          </a:xfrm>
+          <a:prstGeom prst="rect">
+            <a:avLst/>
+          </a:prstGeom>
+          <a:noFill/>
+          <a:ln/>
+        </p:spPr>
+        <p:txBody>
+          <a:bodyPr wrap="square" lIns="0" tIns="0" rIns="0" bIns="0" rtlCol="0" anchor="ctr"/>
+          <a:lstStyle/>
+          <a:p>
+            <a:pPr indent="0" marL="0">
+              <a:buNone/>
+            </a:pPr>
+            <a:r>
+              <a:rPr lang="en-US" sz="1050" dirty="0">
+                <a:solidFill>
+                  <a:srgbClr val="D4622A"/>
+                </a:solidFill>
+                <a:latin typeface="Consolas" pitchFamily="34" charset="0"/>
+                <a:ea typeface="Consolas" pitchFamily="34" charset="-122"/>
+                <a:cs typeface="Consolas" pitchFamily="34" charset="-120"/>
+              </a:rPr>
+              <a:t>SQL</a:t>
+            </a:r>
+            <a:endParaRPr lang="en-US" sz="1050" dirty="0"/>
+          </a:p>
+        </p:txBody>
+      </p:sp>
+      <p:sp>
+        <p:nvSpPr>
+          <p:cNvPr id="42" name="Text 40"/>
+          <p:cNvSpPr txBox="1"/>
+          <p:nvPr/>
+        </p:nvSpPr>
+        <p:spPr>
+          <a:xfrm>
+            <a:off x="3383280" y="5193792"/>
+            <a:ext cx="8138160" cy="365760"/>
+          </a:xfrm>
+          <a:prstGeom prst="rect">
+            <a:avLst/>
+          </a:prstGeom>
+          <a:noFill/>
+          <a:ln/>
+        </p:spPr>
+        <p:txBody>
+          <a:bodyPr wrap="square" lIns="0" tIns="0" rIns="0" bIns="0" rtlCol="0" anchor="ctr"/>
+          <a:lstStyle/>
+          <a:p>
+            <a:pPr indent="0" marL="0">
+              <a:buNone/>
+            </a:pPr>
+            <a:r>
+              <a:rPr lang="en-US" sz="1100" dirty="0">
+                <a:solidFill>
+                  <a:srgbClr val="6B6560"/>
+                </a:solidFill>
+                <a:latin typeface="Calibri" pitchFamily="34" charset="0"/>
+                <a:ea typeface="Calibri" pitchFamily="34" charset="-122"/>
+                <a:cs typeface="Calibri" pitchFamily="34" charset="-120"/>
+              </a:rPr>
+              <a:t>É o COFRE. Guarda tudo e recusa dado que quebre as regras.</a:t>
+            </a:r>
+            <a:endParaRPr lang="en-US" sz="1100" dirty="0"/>
+          </a:p>
+        </p:txBody>
+      </p:sp>
+      <p:sp>
+        <p:nvSpPr>
+          <p:cNvPr id="43" name="Text 41"/>
+          <p:cNvSpPr txBox="1"/>
+          <p:nvPr/>
+        </p:nvSpPr>
+        <p:spPr>
+          <a:xfrm>
+            <a:off x="640080" y="5605272"/>
+            <a:ext cx="1417320" cy="365760"/>
+          </a:xfrm>
+          <a:prstGeom prst="rect">
+            <a:avLst/>
+          </a:prstGeom>
+          <a:noFill/>
+          <a:ln/>
+        </p:spPr>
+        <p:txBody>
+          <a:bodyPr wrap="square" lIns="0" tIns="0" rIns="0" bIns="0" rtlCol="0" anchor="ctr"/>
+          <a:lstStyle/>
+          <a:p>
+            <a:pPr indent="0" marL="0">
+              <a:buNone/>
+            </a:pPr>
+            <a:r>
+              <a:rPr lang="en-US" sz="1150" b="1" dirty="0">
+                <a:solidFill>
+                  <a:srgbClr val="14120F"/>
+                </a:solidFill>
+                <a:latin typeface="Calibri" pitchFamily="34" charset="0"/>
+                <a:ea typeface="Calibri" pitchFamily="34" charset="-122"/>
+                <a:cs typeface="Calibri" pitchFamily="34" charset="-120"/>
+              </a:rPr>
+              <a:t>Jinja</a:t>
+            </a:r>
+            <a:endParaRPr lang="en-US" sz="1150" dirty="0"/>
+          </a:p>
+        </p:txBody>
+      </p:sp>
+      <p:sp>
+        <p:nvSpPr>
+          <p:cNvPr id="44" name="Text 42"/>
+          <p:cNvSpPr txBox="1"/>
+          <p:nvPr/>
+        </p:nvSpPr>
+        <p:spPr>
+          <a:xfrm>
+            <a:off x="2103120" y="5605272"/>
+            <a:ext cx="1188720" cy="365760"/>
+          </a:xfrm>
+          <a:prstGeom prst="rect">
+            <a:avLst/>
+          </a:prstGeom>
+          <a:noFill/>
+          <a:ln/>
+        </p:spPr>
+        <p:txBody>
+          <a:bodyPr wrap="square" lIns="0" tIns="0" rIns="0" bIns="0" rtlCol="0" anchor="ctr"/>
+          <a:lstStyle/>
+          <a:p>
+            <a:pPr indent="0" marL="0">
+              <a:buNone/>
+            </a:pPr>
+            <a:r>
+              <a:rPr lang="en-US" sz="1050" dirty="0">
+                <a:solidFill>
+                  <a:srgbClr val="D4622A"/>
+                </a:solidFill>
+                <a:latin typeface="Consolas" pitchFamily="34" charset="0"/>
+                <a:ea typeface="Consolas" pitchFamily="34" charset="-122"/>
+                <a:cs typeface="Consolas" pitchFamily="34" charset="-120"/>
+              </a:rPr>
+              <a:t>HTML</a:t>
+            </a:r>
+            <a:endParaRPr lang="en-US" sz="1050" dirty="0"/>
+          </a:p>
+        </p:txBody>
+      </p:sp>
+      <p:sp>
+        <p:nvSpPr>
+          <p:cNvPr id="45" name="Text 43"/>
+          <p:cNvSpPr txBox="1"/>
+          <p:nvPr/>
+        </p:nvSpPr>
+        <p:spPr>
+          <a:xfrm>
+            <a:off x="3383280" y="5605272"/>
+            <a:ext cx="8138160" cy="365760"/>
+          </a:xfrm>
+          <a:prstGeom prst="rect">
+            <a:avLst/>
+          </a:prstGeom>
+          <a:noFill/>
+          <a:ln/>
+        </p:spPr>
+        <p:txBody>
+          <a:bodyPr wrap="square" lIns="0" tIns="0" rIns="0" bIns="0" rtlCol="0" anchor="ctr"/>
+          <a:lstStyle/>
+          <a:p>
+            <a:pPr indent="0" marL="0">
+              <a:buNone/>
+            </a:pPr>
+            <a:r>
+              <a:rPr lang="en-US" sz="1100" dirty="0">
+                <a:solidFill>
+                  <a:srgbClr val="6B6560"/>
+                </a:solidFill>
+                <a:latin typeface="Calibri" pitchFamily="34" charset="0"/>
+                <a:ea typeface="Calibri" pitchFamily="34" charset="-122"/>
+                <a:cs typeface="Calibri" pitchFamily="34" charset="-120"/>
+              </a:rPr>
+              <a:t>É o MOLDE da página. Encaixa o dado do banco no HTML que o cliente vê.</a:t>
+            </a:r>
+            <a:endParaRPr lang="en-US" sz="1100" dirty="0"/>
+          </a:p>
+        </p:txBody>
+      </p:sp>
+      <p:sp>
+        <p:nvSpPr>
+          <p:cNvPr id="46" name="Text 44"/>
+          <p:cNvSpPr txBox="1"/>
+          <p:nvPr/>
+        </p:nvSpPr>
+        <p:spPr>
+          <a:xfrm>
+            <a:off x="640080" y="6053328"/>
             <a:ext cx="10908792" cy="365760"/>
           </a:xfrm>
           <a:prstGeom prst="rect">
@@ -7280,7 +7514,7 @@
                 <a:ea typeface="Calibri" pitchFamily="34" charset="-122"/>
                 <a:cs typeface="Calibri" pitchFamily="34" charset="-120"/>
               </a:rPr>
-              <a:t>A stack foi fechada no início e não mudou: PostgreSQL, Python, Flask, SQLAlchemy, Jinja, psycopg 3, gunicorn, pytest e python-dotenv.</a:t>
+              <a:t>A interface é HTML e CSS escritos à mão — sem Bootstrap, sem Tailwind, sem JavaScript nenhum.</a:t>
             </a:r>
             <a:endParaRPr lang="en-US" sz="1250" dirty="0"/>
           </a:p>

</xml_diff>